<commit_message>
Documentation update, error messages and repository cleanup
- DEMO_GUIDE, PRESENTATION_CHECKLIST and docs/COMPLETE_WALKTHROUGH added/updated
- Report and slides updated in docs/
- Smarter user-facing error messages for the Groq integration
- Login page simplification and test suite updates (39 tests)
</commit_message>
<xml_diff>
--- a/docs/DocuQuery_Presentation.pptx
+++ b/docs/DocuQuery_Presentation.pptx
@@ -4564,7 +4564,7 @@
                   <a:srgbClr val="1F2430"/>
                 </a:solidFill>
               </a:rPr>
-              <a:t>•  pytest (33 tests) + Puppeteer browser tests — quality</a:t>
+              <a:t>•  pytest (38+ tests) + headless-Chrome browser tests — quality</a:t>
             </a:r>
           </a:p>
         </p:txBody>
@@ -4711,7 +4711,7 @@
                   <a:srgbClr val="1F2430"/>
                 </a:solidFill>
               </a:rPr>
-              <a:t>•  Works in normal tabs AND sandboxed preview iframes</a:t>
+              <a:t>•  Works in normal tabs and embedded iframes</a:t>
             </a:r>
           </a:p>
           <a:p>
@@ -4858,7 +4858,7 @@
                   <a:srgbClr val="1F2430"/>
                 </a:solidFill>
               </a:rPr>
-              <a:t>•  33/33 automated pytest cases — auth, repository, PDF, embeddings, API</a:t>
+              <a:t>•  38+ automated pytest cases — auth, repository, PDF, embeddings, API</a:t>
             </a:r>
           </a:p>
           <a:p>
@@ -4888,7 +4888,7 @@
                   <a:srgbClr val="1F2430"/>
                 </a:solidFill>
               </a:rPr>
-              <a:t>•  Cross-environment: tab / iframe / sandboxed iframe sign-in flows</a:t>
+              <a:t>•  Sign-in works in tabs and embedded iframes alike</a:t>
             </a:r>
           </a:p>
           <a:p>

</xml_diff>